<commit_message>
Complete Jornadas IA PowerPoint template from Word article content
Fill all 6 slides with GEMEPH data following the official template
structure (portada, objetivo, método, resultados, conclusiones, cierre).

Co-authored-by: Claudio Larrea <claudiomlarrea@users.noreply.github.com>
</commit_message>
<xml_diff>
--- a/JORNADAS IA 2026/Investigacion_UCCuyo_Larrea_GEMEPH.pptx
+++ b/JORNADAS IA 2026/Investigacion_UCCuyo_Larrea_GEMEPH.pptx
@@ -3937,7 +3937,7 @@
               </a:spcAft>
             </a:pPr>
             <a:r>
-              <a:t>¿Qué problema aborda GEMEPH?</a:t>
+              <a:t>¿Qué problema o pregunta aborda el trabajo?</a:t>
             </a:r>
           </a:p>
           <a:p>
@@ -3947,7 +3947,7 @@
               </a:spcAft>
             </a:pPr>
             <a:r>
-              <a:t>• Construir un gemelo digital sociodemográfico sobre microdatos oficiales EPH-INDEC</a:t>
+              <a:t>• Objetivo: construir y validar un gemelo digital sociodemográfico territorial sobre microdatos oficiales EPH-INDEC</a:t>
             </a:r>
           </a:p>
           <a:p>
@@ -3957,7 +3957,7 @@
               </a:spcAft>
             </a:pPr>
             <a:r>
-              <a:t>• Simular escenarios what-if de conectividad, educación y formalidad laboral</a:t>
+              <a:t>• Contexto: la EPH describe la realidad observada, pero no simula escenarios what-if de conectividad, educación y formalidad laboral</a:t>
             </a:r>
           </a:p>
           <a:p>
@@ -3967,12 +3967,12 @@
               </a:spcAft>
             </a:pPr>
             <a:r>
-              <a:t>• Comparar exclusión digital, vulnerabilidad y brechas entre 31 aglomerados urbanos</a:t>
-            </a:r>
-          </a:p>
-          <a:p>
-            <a:r>
-              <a:t>• Aportar evidencia reproducible para investigación y decisión en la UCCuyo</a:t>
+              <a:t>• Institucional: proyecto del Observatorio de Inteligencia Artificial · UCCuyo</a:t>
+            </a:r>
+          </a:p>
+          <a:p>
+            <a:r>
+              <a:t>• Pertinencia regional: comparar exclusión digital y vulnerabilidad en 31 aglomerados urbanos argentinos</a:t>
             </a:r>
           </a:p>
         </p:txBody>
@@ -4397,7 +4397,7 @@
               </a:spcAft>
             </a:pPr>
             <a:r>
-              <a:t>• Panel EPH 2022–2024 (T4, módulo TIC): 114.280 registros; 31 aglomerados + nacional</a:t>
+              <a:t>• Diseño: investigación aplicada tecnológica; panel EPH 2022–2024 (T4, módulo TIC)</a:t>
             </a:r>
           </a:p>
           <a:p>
@@ -4407,7 +4407,7 @@
               </a:spcAft>
             </a:pPr>
             <a:r>
-              <a:t>• Python, scikit-learn, Streamlit; indicadores ponderados (PONDERA)</a:t>
+              <a:t>• Datos: 114.280 registros; indicadores ponderados (PONDERA); 31 aglomerados + nacional</a:t>
             </a:r>
           </a:p>
           <a:p>
@@ -4417,17 +4417,17 @@
               </a:spcAft>
             </a:pPr>
             <a:r>
-              <a:t>• Palancas: internet quintil I, educación superior, empleo formal</a:t>
-            </a:r>
-          </a:p>
-          <a:p>
-            <a:r>
-              <a:t>• Tres escenarios ficticios (E1 conectividad; E2 educación; E3 paquete integrado)</a:t>
-            </a:r>
-          </a:p>
-          <a:p>
-            <a:r>
-              <a:t>• Plataforma pública: eph-analyzer.streamlit.app/GEMEPH</a:t>
+              <a:t>• Herramientas: Python, pandas, scikit-learn, Streamlit, Plotly</a:t>
+            </a:r>
+          </a:p>
+          <a:p>
+            <a:r>
+              <a:t>• Palancas de simulación: internet quintil I, educación superior, empleo formal</a:t>
+            </a:r>
+          </a:p>
+          <a:p>
+            <a:r>
+              <a:t>• Escenarios ficticios E1 (conectividad), E2 (educación 40%), E3 (paquete integrado)</a:t>
             </a:r>
           </a:p>
         </p:txBody>
@@ -4852,7 +4852,7 @@
               </a:spcAft>
             </a:pPr>
             <a:r>
-              <a:t>• Baseline: exclusión digital 0,6205; 53,96% exclusión alta; movilidad proxy 0,4774</a:t>
+              <a:t>• Baseline nacional: exclusión digital 0,6205; 53,96% exclusión alta; movilidad proxy 0,4774; ocupación 58,62%</a:t>
             </a:r>
           </a:p>
           <a:p>
@@ -4862,7 +4862,7 @@
               </a:spcAft>
             </a:pPr>
             <a:r>
-              <a:t>• Brecha territorial: mayor exclusión en Ushuaia–Río Grande; menor en Gran Córdoba</a:t>
+              <a:t>• Brecha territorial: mayor exclusión en Ushuaia–Río Grande (0,6298); menor en Gran Córdoba (0,5979)</a:t>
             </a:r>
           </a:p>
           <a:p>
@@ -4872,17 +4872,17 @@
               </a:spcAft>
             </a:pPr>
             <a:r>
-              <a:t>• E1: efecto marginal de conectividad (cobertura quintil bajo ya en 94,3%)</a:t>
-            </a:r>
-          </a:p>
-          <a:p>
-            <a:r>
-              <a:t>• E2: educación al 40% eleva movilidad proxy +0,0409</a:t>
-            </a:r>
-          </a:p>
-          <a:p>
-            <a:r>
-              <a:t>• E3: paquete integrado reduce exclusión predicha 6,08% → 5,84%</a:t>
+              <a:t>• E1 conectividad inclusiva: efecto marginal (internet quintil bajo ya al 94,3%)</a:t>
+            </a:r>
+          </a:p>
+          <a:p>
+            <a:r>
+              <a:t>• E2 educación superior al 40%: movilidad proxy +0,0409</a:t>
+            </a:r>
+          </a:p>
+          <a:p>
+            <a:r>
+              <a:t>• E3 paquete integrado: exclusión predicha 6,08% → 5,84%</a:t>
             </a:r>
           </a:p>
         </p:txBody>
@@ -5297,7 +5297,7 @@
               </a:spcAft>
             </a:pPr>
             <a:r>
-              <a:t>Mensajes clave</a:t>
+              <a:t>Mensajes clave para llevarse</a:t>
             </a:r>
           </a:p>
           <a:p>
@@ -5307,7 +5307,7 @@
               </a:spcAft>
             </a:pPr>
             <a:r>
-              <a:t>• El gemelo no reemplaza al INDEC: simula sobre el dato oficial con trazabilidad</a:t>
+              <a:t>• GEMEPH no reemplaza al INDEC: simula sobre el dato oficial con trazabilidad</a:t>
             </a:r>
           </a:p>
           <a:p>
@@ -5317,7 +5317,7 @@
               </a:spcAft>
             </a:pPr>
             <a:r>
-              <a:t>• Una sola palanca digital aporta retornos decrecientes; educación y paquetes integrados mueven más indicadores de oportunidad</a:t>
+              <a:t>• La sola conectividad aporta retornos decrecientes; la educación y los paquetes integrados mueven más indicadores de oportunidad</a:t>
             </a:r>
           </a:p>
           <a:p>
@@ -5327,7 +5327,12 @@
               </a:spcAft>
             </a:pPr>
             <a:r>
-              <a:t>• Infraestructura abierta del Observatorio de IA para docencia, investigación y actualización con cada onda EPH</a:t>
+              <a:t>• Plataforma pública del Observatorio de IA, actualizable con cada onda EPH</a:t>
+            </a:r>
+          </a:p>
+          <a:p>
+            <a:r>
+              <a:t>• Próximos pasos: ampliar escenarios, publicaciones y convenios institucionales</a:t>
             </a:r>
           </a:p>
         </p:txBody>

</xml_diff>

<commit_message>
Improve GEMEPH presentation with better text and charts
Add baseline, territorial and scenario comparison charts to slides 4-5.
Rewrite slide copy for clearer oral presentation at Jornadas IA 2026.

Co-authored-by: Claudio Larrea <claudiomlarrea@users.noreply.github.com>
</commit_message>
<xml_diff>
--- a/JORNADAS IA 2026/Investigacion_UCCuyo_Larrea_GEMEPH.pptx
+++ b/JORNADAS IA 2026/Investigacion_UCCuyo_Larrea_GEMEPH.pptx
@@ -5,14 +5,14 @@
     <p:sldMasterId id="2147483648" r:id="rId1"/>
   </p:sldMasterIdLst>
   <p:sldIdLst>
-    <p:sldId id="256" r:id="rId7"/>
-    <p:sldId id="257" r:id="rId8"/>
-    <p:sldId id="258" r:id="rId9"/>
-    <p:sldId id="259" r:id="rId10"/>
-    <p:sldId id="260" r:id="rId11"/>
-    <p:sldId id="261" r:id="rId12"/>
+    <p:sldId id="256" r:id="rId2"/>
+    <p:sldId id="257" r:id="rId3"/>
+    <p:sldId id="258" r:id="rId4"/>
+    <p:sldId id="259" r:id="rId5"/>
+    <p:sldId id="260" r:id="rId6"/>
+    <p:sldId id="261" r:id="rId7"/>
   </p:sldIdLst>
-  <p:sldSz cx="12191695" cy="6858000" type="screen4x3"/>
+  <p:sldSz cx="12192000" cy="6858000"/>
   <p:notesSz cx="6858000" cy="9144000"/>
   <p:defaultTextStyle>
     <a:defPPr>
@@ -109,6 +109,22 @@
       </a:defRPr>
     </a:lvl9pPr>
   </p:defaultTextStyle>
+  <p:extLst>
+    <p:ext uri="{EFAFB233-063F-42B5-8137-9DF3F51BA10A}">
+      <p15:sldGuideLst xmlns:p15="http://schemas.microsoft.com/office/powerpoint/2012/main">
+        <p15:guide id="1" orient="horz" pos="2160">
+          <p15:clr>
+            <a:srgbClr val="A4A3A4"/>
+          </p15:clr>
+        </p15:guide>
+        <p15:guide id="2" pos="2880">
+          <p15:clr>
+            <a:srgbClr val="A4A3A4"/>
+          </p15:clr>
+        </p15:guide>
+      </p15:sldGuideLst>
+    </p:ext>
+  </p:extLst>
 </p:presentation>
 </file>
 
@@ -150,10 +166,9 @@
           <a:lstStyle/>
           <a:p>
             <a:r>
-              <a:rPr lang="en-US" smtClean="0"/>
+              <a:rPr lang="en-US"/>
               <a:t>Click to edit Master title style</a:t>
             </a:r>
-            <a:endParaRPr lang="en-US"/>
           </a:p>
         </p:txBody>
       </p:sp>
@@ -269,10 +284,9 @@
           </a:lstStyle>
           <a:p>
             <a:r>
-              <a:rPr lang="en-US" smtClean="0"/>
+              <a:rPr lang="en-US"/>
               <a:t>Click to edit Master subtitle style</a:t>
             </a:r>
-            <a:endParaRPr lang="en-US"/>
           </a:p>
         </p:txBody>
       </p:sp>
@@ -293,7 +307,7 @@
           <a:p>
             <a:fld id="{5BCAD085-E8A6-8845-BD4E-CB4CCA059FC4}" type="datetimeFigureOut">
               <a:rPr lang="en-US" smtClean="0"/>
-              <a:t>1/27/13</a:t>
+              <a:t>8/22/26</a:t>
             </a:fld>
             <a:endParaRPr lang="en-US"/>
           </a:p>
@@ -335,7 +349,7 @@
           <a:p>
             <a:fld id="{C1FF6DA9-008F-8B48-92A6-B652298478BF}" type="slidenum">
               <a:rPr lang="en-US" smtClean="0"/>
-              <a:t>‹#›</a:t>
+              <a:t>‹Nº›</a:t>
             </a:fld>
             <a:endParaRPr lang="en-US"/>
           </a:p>
@@ -387,10 +401,9 @@
           <a:lstStyle/>
           <a:p>
             <a:r>
-              <a:rPr lang="en-US" smtClean="0"/>
+              <a:rPr lang="en-US"/>
               <a:t>Click to edit Master title style</a:t>
             </a:r>
-            <a:endParaRPr lang="en-US"/>
           </a:p>
         </p:txBody>
       </p:sp>
@@ -411,38 +424,37 @@
           <a:p>
             <a:pPr lvl="0"/>
             <a:r>
-              <a:rPr lang="en-US" smtClean="0"/>
+              <a:rPr lang="en-US"/>
               <a:t>Click to edit Master text styles</a:t>
             </a:r>
           </a:p>
           <a:p>
             <a:pPr lvl="1"/>
             <a:r>
-              <a:rPr lang="en-US" smtClean="0"/>
+              <a:rPr lang="en-US"/>
               <a:t>Second level</a:t>
             </a:r>
           </a:p>
           <a:p>
             <a:pPr lvl="2"/>
             <a:r>
-              <a:rPr lang="en-US" smtClean="0"/>
+              <a:rPr lang="en-US"/>
               <a:t>Third level</a:t>
             </a:r>
           </a:p>
           <a:p>
             <a:pPr lvl="3"/>
             <a:r>
-              <a:rPr lang="en-US" smtClean="0"/>
+              <a:rPr lang="en-US"/>
               <a:t>Fourth level</a:t>
             </a:r>
           </a:p>
           <a:p>
             <a:pPr lvl="4"/>
             <a:r>
-              <a:rPr lang="en-US" smtClean="0"/>
+              <a:rPr lang="en-US"/>
               <a:t>Fifth level</a:t>
             </a:r>
-            <a:endParaRPr lang="en-US"/>
           </a:p>
         </p:txBody>
       </p:sp>
@@ -463,7 +475,7 @@
           <a:p>
             <a:fld id="{5BCAD085-E8A6-8845-BD4E-CB4CCA059FC4}" type="datetimeFigureOut">
               <a:rPr lang="en-US" smtClean="0"/>
-              <a:t>1/27/13</a:t>
+              <a:t>8/22/26</a:t>
             </a:fld>
             <a:endParaRPr lang="en-US"/>
           </a:p>
@@ -505,7 +517,7 @@
           <a:p>
             <a:fld id="{C1FF6DA9-008F-8B48-92A6-B652298478BF}" type="slidenum">
               <a:rPr lang="en-US" smtClean="0"/>
-              <a:t>‹#›</a:t>
+              <a:t>‹Nº›</a:t>
             </a:fld>
             <a:endParaRPr lang="en-US"/>
           </a:p>
@@ -562,10 +574,9 @@
           <a:lstStyle/>
           <a:p>
             <a:r>
-              <a:rPr lang="en-US" smtClean="0"/>
+              <a:rPr lang="en-US"/>
               <a:t>Click to edit Master title style</a:t>
             </a:r>
-            <a:endParaRPr lang="en-US"/>
           </a:p>
         </p:txBody>
       </p:sp>
@@ -591,38 +602,37 @@
           <a:p>
             <a:pPr lvl="0"/>
             <a:r>
-              <a:rPr lang="en-US" smtClean="0"/>
+              <a:rPr lang="en-US"/>
               <a:t>Click to edit Master text styles</a:t>
             </a:r>
           </a:p>
           <a:p>
             <a:pPr lvl="1"/>
             <a:r>
-              <a:rPr lang="en-US" smtClean="0"/>
+              <a:rPr lang="en-US"/>
               <a:t>Second level</a:t>
             </a:r>
           </a:p>
           <a:p>
             <a:pPr lvl="2"/>
             <a:r>
-              <a:rPr lang="en-US" smtClean="0"/>
+              <a:rPr lang="en-US"/>
               <a:t>Third level</a:t>
             </a:r>
           </a:p>
           <a:p>
             <a:pPr lvl="3"/>
             <a:r>
-              <a:rPr lang="en-US" smtClean="0"/>
+              <a:rPr lang="en-US"/>
               <a:t>Fourth level</a:t>
             </a:r>
           </a:p>
           <a:p>
             <a:pPr lvl="4"/>
             <a:r>
-              <a:rPr lang="en-US" smtClean="0"/>
+              <a:rPr lang="en-US"/>
               <a:t>Fifth level</a:t>
             </a:r>
-            <a:endParaRPr lang="en-US"/>
           </a:p>
         </p:txBody>
       </p:sp>
@@ -643,7 +653,7 @@
           <a:p>
             <a:fld id="{5BCAD085-E8A6-8845-BD4E-CB4CCA059FC4}" type="datetimeFigureOut">
               <a:rPr lang="en-US" smtClean="0"/>
-              <a:t>1/27/13</a:t>
+              <a:t>8/22/26</a:t>
             </a:fld>
             <a:endParaRPr lang="en-US"/>
           </a:p>
@@ -685,7 +695,7 @@
           <a:p>
             <a:fld id="{C1FF6DA9-008F-8B48-92A6-B652298478BF}" type="slidenum">
               <a:rPr lang="en-US" smtClean="0"/>
-              <a:t>‹#›</a:t>
+              <a:t>‹Nº›</a:t>
             </a:fld>
             <a:endParaRPr lang="en-US"/>
           </a:p>
@@ -737,10 +747,9 @@
           <a:lstStyle/>
           <a:p>
             <a:r>
-              <a:rPr lang="en-US" smtClean="0"/>
+              <a:rPr lang="en-US"/>
               <a:t>Click to edit Master title style</a:t>
             </a:r>
-            <a:endParaRPr lang="en-US"/>
           </a:p>
         </p:txBody>
       </p:sp>
@@ -761,38 +770,37 @@
           <a:p>
             <a:pPr lvl="0"/>
             <a:r>
-              <a:rPr lang="en-US" smtClean="0"/>
+              <a:rPr lang="en-US"/>
               <a:t>Click to edit Master text styles</a:t>
             </a:r>
           </a:p>
           <a:p>
             <a:pPr lvl="1"/>
             <a:r>
-              <a:rPr lang="en-US" smtClean="0"/>
+              <a:rPr lang="en-US"/>
               <a:t>Second level</a:t>
             </a:r>
           </a:p>
           <a:p>
             <a:pPr lvl="2"/>
             <a:r>
-              <a:rPr lang="en-US" smtClean="0"/>
+              <a:rPr lang="en-US"/>
               <a:t>Third level</a:t>
             </a:r>
           </a:p>
           <a:p>
             <a:pPr lvl="3"/>
             <a:r>
-              <a:rPr lang="en-US" smtClean="0"/>
+              <a:rPr lang="en-US"/>
               <a:t>Fourth level</a:t>
             </a:r>
           </a:p>
           <a:p>
             <a:pPr lvl="4"/>
             <a:r>
-              <a:rPr lang="en-US" smtClean="0"/>
+              <a:rPr lang="en-US"/>
               <a:t>Fifth level</a:t>
             </a:r>
-            <a:endParaRPr lang="en-US"/>
           </a:p>
         </p:txBody>
       </p:sp>
@@ -813,7 +821,7 @@
           <a:p>
             <a:fld id="{5BCAD085-E8A6-8845-BD4E-CB4CCA059FC4}" type="datetimeFigureOut">
               <a:rPr lang="en-US" smtClean="0"/>
-              <a:t>1/27/13</a:t>
+              <a:t>8/22/26</a:t>
             </a:fld>
             <a:endParaRPr lang="en-US"/>
           </a:p>
@@ -855,7 +863,7 @@
           <a:p>
             <a:fld id="{C1FF6DA9-008F-8B48-92A6-B652298478BF}" type="slidenum">
               <a:rPr lang="en-US" smtClean="0"/>
-              <a:t>‹#›</a:t>
+              <a:t>‹Nº›</a:t>
             </a:fld>
             <a:endParaRPr lang="en-US"/>
           </a:p>
@@ -916,10 +924,9 @@
           </a:lstStyle>
           <a:p>
             <a:r>
-              <a:rPr lang="en-US" smtClean="0"/>
+              <a:rPr lang="en-US"/>
               <a:t>Click to edit Master title style</a:t>
             </a:r>
-            <a:endParaRPr lang="en-US"/>
           </a:p>
         </p:txBody>
       </p:sp>
@@ -1036,7 +1043,7 @@
           <a:p>
             <a:pPr lvl="0"/>
             <a:r>
-              <a:rPr lang="en-US" smtClean="0"/>
+              <a:rPr lang="en-US"/>
               <a:t>Click to edit Master text styles</a:t>
             </a:r>
           </a:p>
@@ -1059,7 +1066,7 @@
           <a:p>
             <a:fld id="{5BCAD085-E8A6-8845-BD4E-CB4CCA059FC4}" type="datetimeFigureOut">
               <a:rPr lang="en-US" smtClean="0"/>
-              <a:t>1/27/13</a:t>
+              <a:t>8/22/26</a:t>
             </a:fld>
             <a:endParaRPr lang="en-US"/>
           </a:p>
@@ -1101,7 +1108,7 @@
           <a:p>
             <a:fld id="{C1FF6DA9-008F-8B48-92A6-B652298478BF}" type="slidenum">
               <a:rPr lang="en-US" smtClean="0"/>
-              <a:t>‹#›</a:t>
+              <a:t>‹Nº›</a:t>
             </a:fld>
             <a:endParaRPr lang="en-US"/>
           </a:p>
@@ -1153,10 +1160,9 @@
           <a:lstStyle/>
           <a:p>
             <a:r>
-              <a:rPr lang="en-US" smtClean="0"/>
+              <a:rPr lang="en-US"/>
               <a:t>Click to edit Master title style</a:t>
             </a:r>
-            <a:endParaRPr lang="en-US"/>
           </a:p>
         </p:txBody>
       </p:sp>
@@ -1210,38 +1216,37 @@
           <a:p>
             <a:pPr lvl="0"/>
             <a:r>
-              <a:rPr lang="en-US" smtClean="0"/>
+              <a:rPr lang="en-US"/>
               <a:t>Click to edit Master text styles</a:t>
             </a:r>
           </a:p>
           <a:p>
             <a:pPr lvl="1"/>
             <a:r>
-              <a:rPr lang="en-US" smtClean="0"/>
+              <a:rPr lang="en-US"/>
               <a:t>Second level</a:t>
             </a:r>
           </a:p>
           <a:p>
             <a:pPr lvl="2"/>
             <a:r>
-              <a:rPr lang="en-US" smtClean="0"/>
+              <a:rPr lang="en-US"/>
               <a:t>Third level</a:t>
             </a:r>
           </a:p>
           <a:p>
             <a:pPr lvl="3"/>
             <a:r>
-              <a:rPr lang="en-US" smtClean="0"/>
+              <a:rPr lang="en-US"/>
               <a:t>Fourth level</a:t>
             </a:r>
           </a:p>
           <a:p>
             <a:pPr lvl="4"/>
             <a:r>
-              <a:rPr lang="en-US" smtClean="0"/>
+              <a:rPr lang="en-US"/>
               <a:t>Fifth level</a:t>
             </a:r>
-            <a:endParaRPr lang="en-US"/>
           </a:p>
         </p:txBody>
       </p:sp>
@@ -1295,38 +1300,37 @@
           <a:p>
             <a:pPr lvl="0"/>
             <a:r>
-              <a:rPr lang="en-US" smtClean="0"/>
+              <a:rPr lang="en-US"/>
               <a:t>Click to edit Master text styles</a:t>
             </a:r>
           </a:p>
           <a:p>
             <a:pPr lvl="1"/>
             <a:r>
-              <a:rPr lang="en-US" smtClean="0"/>
+              <a:rPr lang="en-US"/>
               <a:t>Second level</a:t>
             </a:r>
           </a:p>
           <a:p>
             <a:pPr lvl="2"/>
             <a:r>
-              <a:rPr lang="en-US" smtClean="0"/>
+              <a:rPr lang="en-US"/>
               <a:t>Third level</a:t>
             </a:r>
           </a:p>
           <a:p>
             <a:pPr lvl="3"/>
             <a:r>
-              <a:rPr lang="en-US" smtClean="0"/>
+              <a:rPr lang="en-US"/>
               <a:t>Fourth level</a:t>
             </a:r>
           </a:p>
           <a:p>
             <a:pPr lvl="4"/>
             <a:r>
-              <a:rPr lang="en-US" smtClean="0"/>
+              <a:rPr lang="en-US"/>
               <a:t>Fifth level</a:t>
             </a:r>
-            <a:endParaRPr lang="en-US"/>
           </a:p>
         </p:txBody>
       </p:sp>
@@ -1347,7 +1351,7 @@
           <a:p>
             <a:fld id="{5BCAD085-E8A6-8845-BD4E-CB4CCA059FC4}" type="datetimeFigureOut">
               <a:rPr lang="en-US" smtClean="0"/>
-              <a:t>1/27/13</a:t>
+              <a:t>8/22/26</a:t>
             </a:fld>
             <a:endParaRPr lang="en-US"/>
           </a:p>
@@ -1389,7 +1393,7 @@
           <a:p>
             <a:fld id="{C1FF6DA9-008F-8B48-92A6-B652298478BF}" type="slidenum">
               <a:rPr lang="en-US" smtClean="0"/>
-              <a:t>‹#›</a:t>
+              <a:t>‹Nº›</a:t>
             </a:fld>
             <a:endParaRPr lang="en-US"/>
           </a:p>
@@ -1445,10 +1449,9 @@
           </a:lstStyle>
           <a:p>
             <a:r>
-              <a:rPr lang="en-US" smtClean="0"/>
+              <a:rPr lang="en-US"/>
               <a:t>Click to edit Master title style</a:t>
             </a:r>
-            <a:endParaRPr lang="en-US"/>
           </a:p>
         </p:txBody>
       </p:sp>
@@ -1511,7 +1514,7 @@
           <a:p>
             <a:pPr lvl="0"/>
             <a:r>
-              <a:rPr lang="en-US" smtClean="0"/>
+              <a:rPr lang="en-US"/>
               <a:t>Click to edit Master text styles</a:t>
             </a:r>
           </a:p>
@@ -1567,38 +1570,37 @@
           <a:p>
             <a:pPr lvl="0"/>
             <a:r>
-              <a:rPr lang="en-US" smtClean="0"/>
+              <a:rPr lang="en-US"/>
               <a:t>Click to edit Master text styles</a:t>
             </a:r>
           </a:p>
           <a:p>
             <a:pPr lvl="1"/>
             <a:r>
-              <a:rPr lang="en-US" smtClean="0"/>
+              <a:rPr lang="en-US"/>
               <a:t>Second level</a:t>
             </a:r>
           </a:p>
           <a:p>
             <a:pPr lvl="2"/>
             <a:r>
-              <a:rPr lang="en-US" smtClean="0"/>
+              <a:rPr lang="en-US"/>
               <a:t>Third level</a:t>
             </a:r>
           </a:p>
           <a:p>
             <a:pPr lvl="3"/>
             <a:r>
-              <a:rPr lang="en-US" smtClean="0"/>
+              <a:rPr lang="en-US"/>
               <a:t>Fourth level</a:t>
             </a:r>
           </a:p>
           <a:p>
             <a:pPr lvl="4"/>
             <a:r>
-              <a:rPr lang="en-US" smtClean="0"/>
+              <a:rPr lang="en-US"/>
               <a:t>Fifth level</a:t>
             </a:r>
-            <a:endParaRPr lang="en-US"/>
           </a:p>
         </p:txBody>
       </p:sp>
@@ -1661,7 +1663,7 @@
           <a:p>
             <a:pPr lvl="0"/>
             <a:r>
-              <a:rPr lang="en-US" smtClean="0"/>
+              <a:rPr lang="en-US"/>
               <a:t>Click to edit Master text styles</a:t>
             </a:r>
           </a:p>
@@ -1717,38 +1719,37 @@
           <a:p>
             <a:pPr lvl="0"/>
             <a:r>
-              <a:rPr lang="en-US" smtClean="0"/>
+              <a:rPr lang="en-US"/>
               <a:t>Click to edit Master text styles</a:t>
             </a:r>
           </a:p>
           <a:p>
             <a:pPr lvl="1"/>
             <a:r>
-              <a:rPr lang="en-US" smtClean="0"/>
+              <a:rPr lang="en-US"/>
               <a:t>Second level</a:t>
             </a:r>
           </a:p>
           <a:p>
             <a:pPr lvl="2"/>
             <a:r>
-              <a:rPr lang="en-US" smtClean="0"/>
+              <a:rPr lang="en-US"/>
               <a:t>Third level</a:t>
             </a:r>
           </a:p>
           <a:p>
             <a:pPr lvl="3"/>
             <a:r>
-              <a:rPr lang="en-US" smtClean="0"/>
+              <a:rPr lang="en-US"/>
               <a:t>Fourth level</a:t>
             </a:r>
           </a:p>
           <a:p>
             <a:pPr lvl="4"/>
             <a:r>
-              <a:rPr lang="en-US" smtClean="0"/>
+              <a:rPr lang="en-US"/>
               <a:t>Fifth level</a:t>
             </a:r>
-            <a:endParaRPr lang="en-US"/>
           </a:p>
         </p:txBody>
       </p:sp>
@@ -1769,7 +1770,7 @@
           <a:p>
             <a:fld id="{5BCAD085-E8A6-8845-BD4E-CB4CCA059FC4}" type="datetimeFigureOut">
               <a:rPr lang="en-US" smtClean="0"/>
-              <a:t>1/27/13</a:t>
+              <a:t>8/22/26</a:t>
             </a:fld>
             <a:endParaRPr lang="en-US"/>
           </a:p>
@@ -1811,7 +1812,7 @@
           <a:p>
             <a:fld id="{C1FF6DA9-008F-8B48-92A6-B652298478BF}" type="slidenum">
               <a:rPr lang="en-US" smtClean="0"/>
-              <a:t>‹#›</a:t>
+              <a:t>‹Nº›</a:t>
             </a:fld>
             <a:endParaRPr lang="en-US"/>
           </a:p>
@@ -1863,10 +1864,9 @@
           <a:lstStyle/>
           <a:p>
             <a:r>
-              <a:rPr lang="en-US" smtClean="0"/>
+              <a:rPr lang="en-US"/>
               <a:t>Click to edit Master title style</a:t>
             </a:r>
-            <a:endParaRPr lang="en-US"/>
           </a:p>
         </p:txBody>
       </p:sp>
@@ -1887,7 +1887,7 @@
           <a:p>
             <a:fld id="{5BCAD085-E8A6-8845-BD4E-CB4CCA059FC4}" type="datetimeFigureOut">
               <a:rPr lang="en-US" smtClean="0"/>
-              <a:t>1/27/13</a:t>
+              <a:t>8/22/26</a:t>
             </a:fld>
             <a:endParaRPr lang="en-US"/>
           </a:p>
@@ -1929,7 +1929,7 @@
           <a:p>
             <a:fld id="{C1FF6DA9-008F-8B48-92A6-B652298478BF}" type="slidenum">
               <a:rPr lang="en-US" smtClean="0"/>
-              <a:t>‹#›</a:t>
+              <a:t>‹Nº›</a:t>
             </a:fld>
             <a:endParaRPr lang="en-US"/>
           </a:p>
@@ -1982,7 +1982,7 @@
           <a:p>
             <a:fld id="{5BCAD085-E8A6-8845-BD4E-CB4CCA059FC4}" type="datetimeFigureOut">
               <a:rPr lang="en-US" smtClean="0"/>
-              <a:t>1/27/13</a:t>
+              <a:t>8/22/26</a:t>
             </a:fld>
             <a:endParaRPr lang="en-US"/>
           </a:p>
@@ -2024,7 +2024,7 @@
           <a:p>
             <a:fld id="{C1FF6DA9-008F-8B48-92A6-B652298478BF}" type="slidenum">
               <a:rPr lang="en-US" smtClean="0"/>
-              <a:t>‹#›</a:t>
+              <a:t>‹Nº›</a:t>
             </a:fld>
             <a:endParaRPr lang="en-US"/>
           </a:p>
@@ -2085,10 +2085,9 @@
           </a:lstStyle>
           <a:p>
             <a:r>
-              <a:rPr lang="en-US" smtClean="0"/>
+              <a:rPr lang="en-US"/>
               <a:t>Click to edit Master title style</a:t>
             </a:r>
-            <a:endParaRPr lang="en-US"/>
           </a:p>
         </p:txBody>
       </p:sp>
@@ -2142,38 +2141,37 @@
           <a:p>
             <a:pPr lvl="0"/>
             <a:r>
-              <a:rPr lang="en-US" smtClean="0"/>
+              <a:rPr lang="en-US"/>
               <a:t>Click to edit Master text styles</a:t>
             </a:r>
           </a:p>
           <a:p>
             <a:pPr lvl="1"/>
             <a:r>
-              <a:rPr lang="en-US" smtClean="0"/>
+              <a:rPr lang="en-US"/>
               <a:t>Second level</a:t>
             </a:r>
           </a:p>
           <a:p>
             <a:pPr lvl="2"/>
             <a:r>
-              <a:rPr lang="en-US" smtClean="0"/>
+              <a:rPr lang="en-US"/>
               <a:t>Third level</a:t>
             </a:r>
           </a:p>
           <a:p>
             <a:pPr lvl="3"/>
             <a:r>
-              <a:rPr lang="en-US" smtClean="0"/>
+              <a:rPr lang="en-US"/>
               <a:t>Fourth level</a:t>
             </a:r>
           </a:p>
           <a:p>
             <a:pPr lvl="4"/>
             <a:r>
-              <a:rPr lang="en-US" smtClean="0"/>
+              <a:rPr lang="en-US"/>
               <a:t>Fifth level</a:t>
             </a:r>
-            <a:endParaRPr lang="en-US"/>
           </a:p>
         </p:txBody>
       </p:sp>
@@ -2236,7 +2234,7 @@
           <a:p>
             <a:pPr lvl="0"/>
             <a:r>
-              <a:rPr lang="en-US" smtClean="0"/>
+              <a:rPr lang="en-US"/>
               <a:t>Click to edit Master text styles</a:t>
             </a:r>
           </a:p>
@@ -2259,7 +2257,7 @@
           <a:p>
             <a:fld id="{5BCAD085-E8A6-8845-BD4E-CB4CCA059FC4}" type="datetimeFigureOut">
               <a:rPr lang="en-US" smtClean="0"/>
-              <a:t>1/27/13</a:t>
+              <a:t>8/22/26</a:t>
             </a:fld>
             <a:endParaRPr lang="en-US"/>
           </a:p>
@@ -2301,7 +2299,7 @@
           <a:p>
             <a:fld id="{C1FF6DA9-008F-8B48-92A6-B652298478BF}" type="slidenum">
               <a:rPr lang="en-US" smtClean="0"/>
-              <a:t>‹#›</a:t>
+              <a:t>‹Nº›</a:t>
             </a:fld>
             <a:endParaRPr lang="en-US"/>
           </a:p>
@@ -2362,10 +2360,9 @@
           </a:lstStyle>
           <a:p>
             <a:r>
-              <a:rPr lang="en-US" smtClean="0"/>
+              <a:rPr lang="en-US"/>
               <a:t>Click to edit Master title style</a:t>
             </a:r>
-            <a:endParaRPr lang="en-US"/>
           </a:p>
         </p:txBody>
       </p:sp>
@@ -2489,7 +2486,7 @@
           <a:p>
             <a:pPr lvl="0"/>
             <a:r>
-              <a:rPr lang="en-US" smtClean="0"/>
+              <a:rPr lang="en-US"/>
               <a:t>Click to edit Master text styles</a:t>
             </a:r>
           </a:p>
@@ -2512,7 +2509,7 @@
           <a:p>
             <a:fld id="{5BCAD085-E8A6-8845-BD4E-CB4CCA059FC4}" type="datetimeFigureOut">
               <a:rPr lang="en-US" smtClean="0"/>
-              <a:t>1/27/13</a:t>
+              <a:t>8/22/26</a:t>
             </a:fld>
             <a:endParaRPr lang="en-US"/>
           </a:p>
@@ -2554,7 +2551,7 @@
           <a:p>
             <a:fld id="{C1FF6DA9-008F-8B48-92A6-B652298478BF}" type="slidenum">
               <a:rPr lang="en-US" smtClean="0"/>
-              <a:t>‹#›</a:t>
+              <a:t>‹Nº›</a:t>
             </a:fld>
             <a:endParaRPr lang="en-US"/>
           </a:p>
@@ -2621,10 +2618,9 @@
           <a:lstStyle/>
           <a:p>
             <a:r>
-              <a:rPr lang="en-US" smtClean="0"/>
+              <a:rPr lang="en-US"/>
               <a:t>Click to edit Master title style</a:t>
             </a:r>
-            <a:endParaRPr lang="en-US"/>
           </a:p>
         </p:txBody>
       </p:sp>
@@ -2655,38 +2651,37 @@
           <a:p>
             <a:pPr lvl="0"/>
             <a:r>
-              <a:rPr lang="en-US" smtClean="0"/>
+              <a:rPr lang="en-US"/>
               <a:t>Click to edit Master text styles</a:t>
             </a:r>
           </a:p>
           <a:p>
             <a:pPr lvl="1"/>
             <a:r>
-              <a:rPr lang="en-US" smtClean="0"/>
+              <a:rPr lang="en-US"/>
               <a:t>Second level</a:t>
             </a:r>
           </a:p>
           <a:p>
             <a:pPr lvl="2"/>
             <a:r>
-              <a:rPr lang="en-US" smtClean="0"/>
+              <a:rPr lang="en-US"/>
               <a:t>Third level</a:t>
             </a:r>
           </a:p>
           <a:p>
             <a:pPr lvl="3"/>
             <a:r>
-              <a:rPr lang="en-US" smtClean="0"/>
+              <a:rPr lang="en-US"/>
               <a:t>Fourth level</a:t>
             </a:r>
           </a:p>
           <a:p>
             <a:pPr lvl="4"/>
             <a:r>
-              <a:rPr lang="en-US" smtClean="0"/>
+              <a:rPr lang="en-US"/>
               <a:t>Fifth level</a:t>
             </a:r>
-            <a:endParaRPr lang="en-US"/>
           </a:p>
         </p:txBody>
       </p:sp>
@@ -2725,7 +2720,7 @@
           <a:p>
             <a:fld id="{5BCAD085-E8A6-8845-BD4E-CB4CCA059FC4}" type="datetimeFigureOut">
               <a:rPr lang="en-US" smtClean="0"/>
-              <a:t>1/27/13</a:t>
+              <a:t>8/22/26</a:t>
             </a:fld>
             <a:endParaRPr lang="en-US"/>
           </a:p>
@@ -2803,7 +2798,7 @@
           <a:p>
             <a:fld id="{C1FF6DA9-008F-8B48-92A6-B652298478BF}" type="slidenum">
               <a:rPr lang="en-US" smtClean="0"/>
-              <a:t>‹#›</a:t>
+              <a:t>‹Nº›</a:t>
             </a:fld>
             <a:endParaRPr lang="en-US"/>
           </a:p>
@@ -3084,7 +3079,7 @@
 </file>
 
 <file path=ppt/slides/slide1.xml><?xml version="1.0" encoding="utf-8"?>
-<p:sld xmlns:a="http://schemas.openxmlformats.org/drawingml/2006/main" xmlns:p="http://schemas.openxmlformats.org/presentationml/2006/main" xmlns:r="http://schemas.openxmlformats.org/officeDocument/2006/relationships">
+<p:sld xmlns:a="http://schemas.openxmlformats.org/drawingml/2006/main" xmlns:r="http://schemas.openxmlformats.org/officeDocument/2006/relationships" xmlns:p="http://schemas.openxmlformats.org/presentationml/2006/main">
   <p:cSld>
     <p:spTree>
       <p:nvGrpSpPr>
@@ -3092,7 +3087,14 @@
         <p:cNvGrpSpPr/>
         <p:nvPr/>
       </p:nvGrpSpPr>
-      <p:grpSpPr/>
+      <p:grpSpPr>
+        <a:xfrm>
+          <a:off x="0" y="0"/>
+          <a:ext cx="0" cy="0"/>
+          <a:chOff x="0" y="0"/>
+          <a:chExt cx="0" cy="0"/>
+        </a:xfrm>
+      </p:grpSpPr>
       <p:sp>
         <p:nvSpPr>
           <p:cNvPr id="2" name="Rectangle 1"/>
@@ -3133,6 +3135,7 @@
           <a:lstStyle/>
           <a:p>
             <a:pPr algn="ctr"/>
+            <a:endParaRPr/>
           </a:p>
         </p:txBody>
       </p:sp>
@@ -3176,6 +3179,7 @@
           <a:lstStyle/>
           <a:p>
             <a:pPr algn="ctr"/>
+            <a:endParaRPr/>
           </a:p>
         </p:txBody>
       </p:sp>
@@ -3219,6 +3223,7 @@
           <a:lstStyle/>
           <a:p>
             <a:pPr algn="ctr"/>
+            <a:endParaRPr/>
           </a:p>
         </p:txBody>
       </p:sp>
@@ -3357,6 +3362,7 @@
           <a:lstStyle/>
           <a:p>
             <a:pPr algn="ctr"/>
+            <a:endParaRPr/>
           </a:p>
         </p:txBody>
       </p:sp>
@@ -3476,7 +3482,7 @@
           </a:fontRef>
         </p:style>
         <p:txBody>
-          <a:bodyPr rtlCol="0" anchor="ctr" wrap="square"/>
+          <a:bodyPr wrap="square" rtlCol="0" anchor="ctr"/>
           <a:lstStyle/>
           <a:p>
             <a:pPr algn="l">
@@ -3485,7 +3491,7 @@
               </a:spcAft>
             </a:pPr>
             <a:r>
-              <a:t>GEMEPH: gemelo digital sociodemográfico de la EPH-INDEC para simular exclusión digital, vulnerabilidad y brechas territoriales en Argentina</a:t>
+              <a:t>GEMEPH</a:t>
             </a:r>
           </a:p>
           <a:p>
@@ -3494,6 +3500,14 @@
                 <a:spcPts val="800"/>
               </a:spcAft>
             </a:pPr>
+            <a:r>
+              <a:t>Gemelo digital sociodemográfico de la EPH-INDEC</a:t>
+            </a:r>
+            <a:endParaRPr dirty="0">
+              <a:solidFill>
+                <a:schemeClr val="tx1"/>
+              </a:solidFill>
+            </a:endParaRPr>
           </a:p>
           <a:p>
             <a:pPr algn="l">
@@ -3501,9 +3515,6 @@
                 <a:spcPts val="800"/>
               </a:spcAft>
             </a:pPr>
-            <a:r>
-              <a:t>Autores: C. Larrea Arnau¹, J. La Malfa², J. Coria¹, S. Young¹</a:t>
-            </a:r>
           </a:p>
           <a:p>
             <a:pPr algn="l">
@@ -3512,7 +3523,7 @@
               </a:spcAft>
             </a:pPr>
             <a:r>
-              <a:t>Observatorio de Inteligencia Artificial — Universidad Católica de Cuyo</a:t>
+              <a:t>Exclusión digital, vulnerabilidad y brechas territoriales en Argentina</a:t>
             </a:r>
           </a:p>
           <a:p>
@@ -3521,6 +3532,23 @@
                 <a:spcPts val="800"/>
               </a:spcAft>
             </a:pPr>
+            <a:endParaRPr dirty="0">
+              <a:solidFill>
+                <a:schemeClr val="tx1"/>
+              </a:solidFill>
+            </a:endParaRPr>
+          </a:p>
+          <a:p>
+            <a:r>
+              <a:t>C. Larrea Arnau¹ · J. La Malfa · J. Coria · S. Young · B. Arias · L. Pizarro</a:t>
+            </a:r>
+          </a:p>
+          <a:p>
+            <a:r>
+              <a:t>Observatorio de Inteligencia Artificial — Universidad Católica de Cuyo</a:t>
+            </a:r>
+          </a:p>
+          <a:p>
             <a:r>
               <a:t>observatorioia@uccuyo.edu.ar</a:t>
             </a:r>
@@ -3536,7 +3564,7 @@
 </file>
 
 <file path=ppt/slides/slide2.xml><?xml version="1.0" encoding="utf-8"?>
-<p:sld xmlns:a="http://schemas.openxmlformats.org/drawingml/2006/main" xmlns:p="http://schemas.openxmlformats.org/presentationml/2006/main" xmlns:r="http://schemas.openxmlformats.org/officeDocument/2006/relationships">
+<p:sld xmlns:a="http://schemas.openxmlformats.org/drawingml/2006/main" xmlns:r="http://schemas.openxmlformats.org/officeDocument/2006/relationships" xmlns:p="http://schemas.openxmlformats.org/presentationml/2006/main">
   <p:cSld>
     <p:spTree>
       <p:nvGrpSpPr>
@@ -3544,7 +3572,14 @@
         <p:cNvGrpSpPr/>
         <p:nvPr/>
       </p:nvGrpSpPr>
-      <p:grpSpPr/>
+      <p:grpSpPr>
+        <a:xfrm>
+          <a:off x="0" y="0"/>
+          <a:ext cx="0" cy="0"/>
+          <a:chOff x="0" y="0"/>
+          <a:chExt cx="0" cy="0"/>
+        </a:xfrm>
+      </p:grpSpPr>
       <p:sp>
         <p:nvSpPr>
           <p:cNvPr id="2" name="Rectangle 1"/>
@@ -3585,6 +3620,7 @@
           <a:lstStyle/>
           <a:p>
             <a:pPr algn="ctr"/>
+            <a:endParaRPr/>
           </a:p>
         </p:txBody>
       </p:sp>
@@ -3628,6 +3664,7 @@
           <a:lstStyle/>
           <a:p>
             <a:pPr algn="ctr"/>
+            <a:endParaRPr/>
           </a:p>
         </p:txBody>
       </p:sp>
@@ -3671,6 +3708,7 @@
           <a:lstStyle/>
           <a:p>
             <a:pPr algn="ctr"/>
+            <a:endParaRPr/>
           </a:p>
         </p:txBody>
       </p:sp>
@@ -3809,6 +3847,7 @@
           <a:lstStyle/>
           <a:p>
             <a:pPr algn="ctr"/>
+            <a:endParaRPr/>
           </a:p>
         </p:txBody>
       </p:sp>
@@ -3928,7 +3967,7 @@
           </a:fontRef>
         </p:style>
         <p:txBody>
-          <a:bodyPr rtlCol="0" anchor="ctr" wrap="square"/>
+          <a:bodyPr wrap="square" rtlCol="0" anchor="ctr"/>
           <a:lstStyle/>
           <a:p>
             <a:pPr algn="l">
@@ -3937,7 +3976,7 @@
               </a:spcAft>
             </a:pPr>
             <a:r>
-              <a:t>¿Qué problema o pregunta aborda el trabajo?</a:t>
+              <a:t>¿Por qué un gemelo digital sobre la EPH?</a:t>
             </a:r>
           </a:p>
           <a:p>
@@ -3947,7 +3986,7 @@
               </a:spcAft>
             </a:pPr>
             <a:r>
-              <a:t>• Objetivo: construir y validar un gemelo digital sociodemográfico territorial sobre microdatos oficiales EPH-INDEC</a:t>
+              <a:t>• La Encuesta Permanente de Hogares (INDEC) es la fuente oficial para estudiar vida, empleo, educación y TIC en el aglomerado urbano argentino.</a:t>
             </a:r>
           </a:p>
           <a:p>
@@ -3957,8 +3996,13 @@
               </a:spcAft>
             </a:pPr>
             <a:r>
-              <a:t>• Contexto: la EPH describe la realidad observada, pero no simula escenarios what-if de conectividad, educación y formalidad laboral</a:t>
-            </a:r>
+              <a:t>• Sin embargo, la EPH describe el presente: no permite explorar de forma sistemática qué ocurriría si mejoran conectividad, educación o formalidad laboral.</a:t>
+            </a:r>
+            <a:endParaRPr dirty="0">
+              <a:solidFill>
+                <a:schemeClr val="tx1"/>
+              </a:solidFill>
+            </a:endParaRPr>
           </a:p>
           <a:p>
             <a:pPr algn="l">
@@ -3967,13 +4011,23 @@
               </a:spcAft>
             </a:pPr>
             <a:r>
-              <a:t>• Institucional: proyecto del Observatorio de Inteligencia Artificial · UCCuyo</a:t>
-            </a:r>
-          </a:p>
-          <a:p>
-            <a:r>
-              <a:t>• Pertinencia regional: comparar exclusión digital y vulnerabilidad en 31 aglomerados urbanos argentinos</a:t>
-            </a:r>
+              <a:t>• GEMEPH representa el dato oficial y lo expone a escenarios contrafactuales (what-if) con trazabilidad y reproducibilidad.</a:t>
+            </a:r>
+            <a:endParaRPr dirty="0">
+              <a:solidFill>
+                <a:schemeClr val="tx1"/>
+              </a:solidFill>
+            </a:endParaRPr>
+          </a:p>
+          <a:p>
+            <a:r>
+              <a:t>• Objetivo: apoyar investigación, docencia y decisión en el Observatorio de IA · UCCuyo, con evidencia comparable en 31 aglomerados.</a:t>
+            </a:r>
+            <a:endParaRPr dirty="0">
+              <a:solidFill>
+                <a:schemeClr val="tx1"/>
+              </a:solidFill>
+            </a:endParaRPr>
           </a:p>
         </p:txBody>
       </p:sp>
@@ -3986,7 +4040,7 @@
 </file>
 
 <file path=ppt/slides/slide3.xml><?xml version="1.0" encoding="utf-8"?>
-<p:sld xmlns:a="http://schemas.openxmlformats.org/drawingml/2006/main" xmlns:p="http://schemas.openxmlformats.org/presentationml/2006/main" xmlns:r="http://schemas.openxmlformats.org/officeDocument/2006/relationships">
+<p:sld xmlns:a="http://schemas.openxmlformats.org/drawingml/2006/main" xmlns:r="http://schemas.openxmlformats.org/officeDocument/2006/relationships" xmlns:p="http://schemas.openxmlformats.org/presentationml/2006/main">
   <p:cSld>
     <p:spTree>
       <p:nvGrpSpPr>
@@ -3994,7 +4048,14 @@
         <p:cNvGrpSpPr/>
         <p:nvPr/>
       </p:nvGrpSpPr>
-      <p:grpSpPr/>
+      <p:grpSpPr>
+        <a:xfrm>
+          <a:off x="0" y="0"/>
+          <a:ext cx="0" cy="0"/>
+          <a:chOff x="0" y="0"/>
+          <a:chExt cx="0" cy="0"/>
+        </a:xfrm>
+      </p:grpSpPr>
       <p:sp>
         <p:nvSpPr>
           <p:cNvPr id="2" name="Rectangle 1"/>
@@ -4035,6 +4096,7 @@
           <a:lstStyle/>
           <a:p>
             <a:pPr algn="ctr"/>
+            <a:endParaRPr/>
           </a:p>
         </p:txBody>
       </p:sp>
@@ -4078,6 +4140,7 @@
           <a:lstStyle/>
           <a:p>
             <a:pPr algn="ctr"/>
+            <a:endParaRPr/>
           </a:p>
         </p:txBody>
       </p:sp>
@@ -4121,6 +4184,7 @@
           <a:lstStyle/>
           <a:p>
             <a:pPr algn="ctr"/>
+            <a:endParaRPr/>
           </a:p>
         </p:txBody>
       </p:sp>
@@ -4259,6 +4323,7 @@
           <a:lstStyle/>
           <a:p>
             <a:pPr algn="ctr"/>
+            <a:endParaRPr/>
           </a:p>
         </p:txBody>
       </p:sp>
@@ -4378,7 +4443,7 @@
           </a:fontRef>
         </p:style>
         <p:txBody>
-          <a:bodyPr rtlCol="0" anchor="ctr" wrap="square"/>
+          <a:bodyPr wrap="square" rtlCol="0" anchor="ctr"/>
           <a:lstStyle/>
           <a:p>
             <a:pPr algn="l">
@@ -4387,7 +4452,7 @@
               </a:spcAft>
             </a:pPr>
             <a:r>
-              <a:t>¿Cómo se hizo?</a:t>
+              <a:t>¿Cómo funciona GEMEPH?</a:t>
             </a:r>
           </a:p>
           <a:p>
@@ -4397,8 +4462,13 @@
               </a:spcAft>
             </a:pPr>
             <a:r>
-              <a:t>• Diseño: investigación aplicada tecnológica; panel EPH 2022–2024 (T4, módulo TIC)</a:t>
-            </a:r>
+              <a:t>• Integración de microdatos EPH 2022–2024 (4.º trimestre, módulo TIC): 114.280 registros individuales, ponderados con PONDERA.</a:t>
+            </a:r>
+            <a:endParaRPr dirty="0">
+              <a:solidFill>
+                <a:schemeClr val="tx1"/>
+              </a:solidFill>
+            </a:endParaRPr>
           </a:p>
           <a:p>
             <a:pPr algn="l">
@@ -4407,7 +4477,7 @@
               </a:spcAft>
             </a:pPr>
             <a:r>
-              <a:t>• Datos: 114.280 registros; indicadores ponderados (PONDERA); 31 aglomerados + nacional</a:t>
+              <a:t>• Cálculo de indicadores: exclusión digital, vulnerabilidad social, movilidad proxy, ocupación, educación e informalidad.</a:t>
             </a:r>
           </a:p>
           <a:p>
@@ -4417,17 +4487,22 @@
               </a:spcAft>
             </a:pPr>
             <a:r>
-              <a:t>• Herramientas: Python, pandas, scikit-learn, Streamlit, Plotly</a:t>
-            </a:r>
-          </a:p>
-          <a:p>
-            <a:r>
-              <a:t>• Palancas de simulación: internet quintil I, educación superior, empleo formal</a:t>
-            </a:r>
-          </a:p>
-          <a:p>
-            <a:r>
-              <a:t>• Escenarios ficticios E1 (conectividad), E2 (educación 40%), E3 (paquete integrado)</a:t>
+              <a:t>• Modelado en Python (pandas, scikit-learn): perfiles k-means y predicción de exclusión digital alta.</a:t>
+            </a:r>
+          </a:p>
+          <a:p>
+            <a:r>
+              <a:t>• Simulación mediante tres palancas: internet en quintil I, educación superior completa y empleo formal.</a:t>
+            </a:r>
+          </a:p>
+          <a:p>
+            <a:r>
+              <a:t>• Tres escenarios ficticios — E1 conectividad · E2 educación al 40% · E3 paquete integrado — sobre un mismo baseline oficial.</a:t>
+            </a:r>
+          </a:p>
+          <a:p>
+            <a:r>
+              <a:t>• Plataforma pública: eph-analyzer.streamlit.app/GEMEPH</a:t>
             </a:r>
           </a:p>
         </p:txBody>
@@ -4441,7 +4516,7 @@
 </file>
 
 <file path=ppt/slides/slide4.xml><?xml version="1.0" encoding="utf-8"?>
-<p:sld xmlns:a="http://schemas.openxmlformats.org/drawingml/2006/main" xmlns:p="http://schemas.openxmlformats.org/presentationml/2006/main" xmlns:r="http://schemas.openxmlformats.org/officeDocument/2006/relationships">
+<p:sld xmlns:a="http://schemas.openxmlformats.org/drawingml/2006/main" xmlns:r="http://schemas.openxmlformats.org/officeDocument/2006/relationships" xmlns:p="http://schemas.openxmlformats.org/presentationml/2006/main">
   <p:cSld>
     <p:spTree>
       <p:nvGrpSpPr>
@@ -4449,7 +4524,14 @@
         <p:cNvGrpSpPr/>
         <p:nvPr/>
       </p:nvGrpSpPr>
-      <p:grpSpPr/>
+      <p:grpSpPr>
+        <a:xfrm>
+          <a:off x="0" y="0"/>
+          <a:ext cx="0" cy="0"/>
+          <a:chOff x="0" y="0"/>
+          <a:chExt cx="0" cy="0"/>
+        </a:xfrm>
+      </p:grpSpPr>
       <p:sp>
         <p:nvSpPr>
           <p:cNvPr id="2" name="Rectangle 1"/>
@@ -4490,6 +4572,7 @@
           <a:lstStyle/>
           <a:p>
             <a:pPr algn="ctr"/>
+            <a:endParaRPr/>
           </a:p>
         </p:txBody>
       </p:sp>
@@ -4533,6 +4616,7 @@
           <a:lstStyle/>
           <a:p>
             <a:pPr algn="ctr"/>
+            <a:endParaRPr/>
           </a:p>
         </p:txBody>
       </p:sp>
@@ -4576,6 +4660,7 @@
           <a:lstStyle/>
           <a:p>
             <a:pPr algn="ctr"/>
+            <a:endParaRPr/>
           </a:p>
         </p:txBody>
       </p:sp>
@@ -4714,6 +4799,7 @@
           <a:lstStyle/>
           <a:p>
             <a:pPr algn="ctr"/>
+            <a:endParaRPr/>
           </a:p>
         </p:txBody>
       </p:sp>
@@ -4804,7 +4890,7 @@
         <p:spPr>
           <a:xfrm>
             <a:off x="548640" y="1920240"/>
-            <a:ext cx="11064240" cy="4206240"/>
+            <a:ext cx="5577840" cy="4206240"/>
           </a:xfrm>
           <a:prstGeom prst="roundRect">
             <a:avLst/>
@@ -4833,7 +4919,7 @@
           </a:fontRef>
         </p:style>
         <p:txBody>
-          <a:bodyPr rtlCol="0" anchor="ctr" wrap="square"/>
+          <a:bodyPr wrap="square" rtlCol="0" anchor="ctr"/>
           <a:lstStyle/>
           <a:p>
             <a:pPr algn="l">
@@ -4842,7 +4928,7 @@
               </a:spcAft>
             </a:pPr>
             <a:r>
-              <a:t>¿Qué se obtuvo?</a:t>
+              <a:t>Resultados del baseline oficial</a:t>
             </a:r>
           </a:p>
           <a:p>
@@ -4852,7 +4938,7 @@
               </a:spcAft>
             </a:pPr>
             <a:r>
-              <a:t>• Baseline nacional: exclusión digital 0,6205; 53,96% exclusión alta; movilidad proxy 0,4774; ocupación 58,62%</a:t>
+              <a:t>• Exclusión digital: 0,62 — 54% en exclusión alta.</a:t>
             </a:r>
           </a:p>
           <a:p>
@@ -4862,7 +4948,7 @@
               </a:spcAft>
             </a:pPr>
             <a:r>
-              <a:t>• Brecha territorial: mayor exclusión en Ushuaia–Río Grande (0,6298); menor en Gran Córdoba (0,5979)</a:t>
+              <a:t>• Vulnerabilidad: 0,27 · Movilidad proxy: 0,48.</a:t>
             </a:r>
           </a:p>
           <a:p>
@@ -4872,21 +4958,69 @@
               </a:spcAft>
             </a:pPr>
             <a:r>
-              <a:t>• E1 conectividad inclusiva: efecto marginal (internet quintil bajo ya al 94,3%)</a:t>
-            </a:r>
-          </a:p>
-          <a:p>
-            <a:r>
-              <a:t>• E2 educación superior al 40%: movilidad proxy +0,0409</a:t>
-            </a:r>
-          </a:p>
-          <a:p>
-            <a:r>
-              <a:t>• E3 paquete integrado: exclusión predicha 6,08% → 5,84%</a:t>
-            </a:r>
-          </a:p>
-        </p:txBody>
-      </p:sp>
+              <a:t>• Fuerte heterogeneidad entre los 31 aglomerados urbanos.</a:t>
+            </a:r>
+          </a:p>
+          <a:p>
+            <a:r>
+              <a:t>• Ushuaia–Río Grande lidera el ranking; Gran Córdoba, el valor más bajo.</a:t>
+            </a:r>
+          </a:p>
+          <a:p>
+            <a:r>
+              <a:t>• El gemelo actualiza estas brechas con cada onda del INDEC.</a:t>
+            </a:r>
+          </a:p>
+        </p:txBody>
+      </p:sp>
+      <p:pic>
+        <p:nvPicPr>
+          <p:cNvPr id="11" name="Picture 10" descr="01_baseline_indicadores.png"/>
+          <p:cNvPicPr>
+            <a:picLocks noChangeAspect="1"/>
+          </p:cNvPicPr>
+          <p:nvPr/>
+        </p:nvPicPr>
+        <p:blipFill>
+          <a:blip r:embed="rId3"/>
+          <a:stretch>
+            <a:fillRect/>
+          </a:stretch>
+        </p:blipFill>
+        <p:spPr>
+          <a:xfrm>
+            <a:off x="5989320" y="2011680"/>
+            <a:ext cx="5669280" cy="2149602"/>
+          </a:xfrm>
+          <a:prstGeom prst="rect">
+            <a:avLst/>
+          </a:prstGeom>
+        </p:spPr>
+      </p:pic>
+      <p:pic>
+        <p:nvPicPr>
+          <p:cNvPr id="12" name="Picture 11" descr="02_brecha_territorial.png"/>
+          <p:cNvPicPr>
+            <a:picLocks noChangeAspect="1"/>
+          </p:cNvPicPr>
+          <p:nvPr/>
+        </p:nvPicPr>
+        <p:blipFill>
+          <a:blip r:embed="rId4"/>
+          <a:stretch>
+            <a:fillRect/>
+          </a:stretch>
+        </p:blipFill>
+        <p:spPr>
+          <a:xfrm>
+            <a:off x="5989320" y="3977639"/>
+            <a:ext cx="5669280" cy="2125980"/>
+          </a:xfrm>
+          <a:prstGeom prst="rect">
+            <a:avLst/>
+          </a:prstGeom>
+        </p:spPr>
+      </p:pic>
     </p:spTree>
   </p:cSld>
   <p:clrMapOvr>
@@ -4896,7 +5030,7 @@
 </file>
 
 <file path=ppt/slides/slide5.xml><?xml version="1.0" encoding="utf-8"?>
-<p:sld xmlns:a="http://schemas.openxmlformats.org/drawingml/2006/main" xmlns:p="http://schemas.openxmlformats.org/presentationml/2006/main" xmlns:r="http://schemas.openxmlformats.org/officeDocument/2006/relationships">
+<p:sld xmlns:a="http://schemas.openxmlformats.org/drawingml/2006/main" xmlns:r="http://schemas.openxmlformats.org/officeDocument/2006/relationships" xmlns:p="http://schemas.openxmlformats.org/presentationml/2006/main">
   <p:cSld>
     <p:spTree>
       <p:nvGrpSpPr>
@@ -4904,7 +5038,14 @@
         <p:cNvGrpSpPr/>
         <p:nvPr/>
       </p:nvGrpSpPr>
-      <p:grpSpPr/>
+      <p:grpSpPr>
+        <a:xfrm>
+          <a:off x="0" y="0"/>
+          <a:ext cx="0" cy="0"/>
+          <a:chOff x="0" y="0"/>
+          <a:chExt cx="0" cy="0"/>
+        </a:xfrm>
+      </p:grpSpPr>
       <p:sp>
         <p:nvSpPr>
           <p:cNvPr id="2" name="Rectangle 1"/>
@@ -4945,6 +5086,7 @@
           <a:lstStyle/>
           <a:p>
             <a:pPr algn="ctr"/>
+            <a:endParaRPr/>
           </a:p>
         </p:txBody>
       </p:sp>
@@ -4988,6 +5130,7 @@
           <a:lstStyle/>
           <a:p>
             <a:pPr algn="ctr"/>
+            <a:endParaRPr/>
           </a:p>
         </p:txBody>
       </p:sp>
@@ -5031,6 +5174,7 @@
           <a:lstStyle/>
           <a:p>
             <a:pPr algn="ctr"/>
+            <a:endParaRPr/>
           </a:p>
         </p:txBody>
       </p:sp>
@@ -5169,6 +5313,7 @@
           <a:lstStyle/>
           <a:p>
             <a:pPr algn="ctr"/>
+            <a:endParaRPr/>
           </a:p>
         </p:txBody>
       </p:sp>
@@ -5259,7 +5404,7 @@
         <p:spPr>
           <a:xfrm>
             <a:off x="548640" y="1920240"/>
-            <a:ext cx="11064240" cy="4206240"/>
+            <a:ext cx="5577840" cy="4206240"/>
           </a:xfrm>
           <a:prstGeom prst="roundRect">
             <a:avLst/>
@@ -5288,7 +5433,7 @@
           </a:fontRef>
         </p:style>
         <p:txBody>
-          <a:bodyPr rtlCol="0" anchor="ctr" wrap="square"/>
+          <a:bodyPr wrap="square" rtlCol="0" anchor="ctr"/>
           <a:lstStyle/>
           <a:p>
             <a:pPr algn="l">
@@ -5297,7 +5442,7 @@
               </a:spcAft>
             </a:pPr>
             <a:r>
-              <a:t>Mensajes clave para llevarse</a:t>
+              <a:t>Tres escenarios, tres lecciones</a:t>
             </a:r>
           </a:p>
           <a:p>
@@ -5307,8 +5452,13 @@
               </a:spcAft>
             </a:pPr>
             <a:r>
-              <a:t>• GEMEPH no reemplaza al INDEC: simula sobre el dato oficial con trazabilidad</a:t>
-            </a:r>
+              <a:t>• E1 Conectividad: efecto marginal (quintil bajo ya al 94% de internet).</a:t>
+            </a:r>
+            <a:endParaRPr dirty="0">
+              <a:solidFill>
+                <a:schemeClr val="tx1"/>
+              </a:solidFill>
+            </a:endParaRPr>
           </a:p>
           <a:p>
             <a:pPr algn="l">
@@ -5317,8 +5467,13 @@
               </a:spcAft>
             </a:pPr>
             <a:r>
-              <a:t>• La sola conectividad aporta retornos decrecientes; la educación y los paquetes integrados mueven más indicadores de oportunidad</a:t>
-            </a:r>
+              <a:t>• E2 Educación al 40%: mayor impacto en movilidad proxy (+0,04).</a:t>
+            </a:r>
+            <a:endParaRPr dirty="0">
+              <a:solidFill>
+                <a:schemeClr val="tx1"/>
+              </a:solidFill>
+            </a:endParaRPr>
           </a:p>
           <a:p>
             <a:pPr algn="l">
@@ -5327,16 +5482,45 @@
               </a:spcAft>
             </a:pPr>
             <a:r>
-              <a:t>• Plataforma pública del Observatorio de IA, actualizable con cada onda EPH</a:t>
-            </a:r>
-          </a:p>
-          <a:p>
-            <a:r>
-              <a:t>• Próximos pasos: ampliar escenarios, publicaciones y convenios institucionales</a:t>
-            </a:r>
-          </a:p>
-        </p:txBody>
-      </p:sp>
+              <a:t>• E3 Paquete integrado: efecto más equilibrado; exclusión predicha 5,84%.</a:t>
+            </a:r>
+          </a:p>
+          <a:p>
+            <a:r>
+              <a:t>• Una sola palanca digital no basta: conviene combinar políticas.</a:t>
+            </a:r>
+          </a:p>
+          <a:p>
+            <a:r>
+              <a:t>• El gemelo anticipa magnitudes de cambio sin reemplazar al INDEC.</a:t>
+            </a:r>
+          </a:p>
+        </p:txBody>
+      </p:sp>
+      <p:pic>
+        <p:nvPicPr>
+          <p:cNvPr id="11" name="Picture 10" descr="03_comparacion_escenarios.png"/>
+          <p:cNvPicPr>
+            <a:picLocks noChangeAspect="1"/>
+          </p:cNvPicPr>
+          <p:nvPr/>
+        </p:nvPicPr>
+        <p:blipFill>
+          <a:blip r:embed="rId3"/>
+          <a:stretch>
+            <a:fillRect/>
+          </a:stretch>
+        </p:blipFill>
+        <p:spPr>
+          <a:xfrm>
+            <a:off x="5989320" y="2103120"/>
+            <a:ext cx="5669280" cy="2608401"/>
+          </a:xfrm>
+          <a:prstGeom prst="rect">
+            <a:avLst/>
+          </a:prstGeom>
+        </p:spPr>
+      </p:pic>
     </p:spTree>
   </p:cSld>
   <p:clrMapOvr>
@@ -5346,7 +5530,7 @@
 </file>
 
 <file path=ppt/slides/slide6.xml><?xml version="1.0" encoding="utf-8"?>
-<p:sld xmlns:a="http://schemas.openxmlformats.org/drawingml/2006/main" xmlns:p="http://schemas.openxmlformats.org/presentationml/2006/main" xmlns:r="http://schemas.openxmlformats.org/officeDocument/2006/relationships">
+<p:sld xmlns:a="http://schemas.openxmlformats.org/drawingml/2006/main" xmlns:r="http://schemas.openxmlformats.org/officeDocument/2006/relationships" xmlns:p="http://schemas.openxmlformats.org/presentationml/2006/main">
   <p:cSld>
     <p:spTree>
       <p:nvGrpSpPr>
@@ -5354,7 +5538,14 @@
         <p:cNvGrpSpPr/>
         <p:nvPr/>
       </p:nvGrpSpPr>
-      <p:grpSpPr/>
+      <p:grpSpPr>
+        <a:xfrm>
+          <a:off x="0" y="0"/>
+          <a:ext cx="0" cy="0"/>
+          <a:chOff x="0" y="0"/>
+          <a:chExt cx="0" cy="0"/>
+        </a:xfrm>
+      </p:grpSpPr>
       <p:sp>
         <p:nvSpPr>
           <p:cNvPr id="2" name="Rectangle 1"/>
@@ -5395,6 +5586,7 @@
           <a:lstStyle/>
           <a:p>
             <a:pPr algn="ctr"/>
+            <a:endParaRPr/>
           </a:p>
         </p:txBody>
       </p:sp>
@@ -5438,6 +5630,7 @@
           <a:lstStyle/>
           <a:p>
             <a:pPr algn="ctr"/>
+            <a:endParaRPr/>
           </a:p>
         </p:txBody>
       </p:sp>
@@ -5481,6 +5674,7 @@
           <a:lstStyle/>
           <a:p>
             <a:pPr algn="ctr"/>
+            <a:endParaRPr/>
           </a:p>
         </p:txBody>
       </p:sp>
@@ -5619,6 +5813,7 @@
           <a:lstStyle/>
           <a:p>
             <a:pPr algn="ctr"/>
+            <a:endParaRPr/>
           </a:p>
         </p:txBody>
       </p:sp>
@@ -5738,7 +5933,7 @@
           </a:fontRef>
         </p:style>
         <p:txBody>
-          <a:bodyPr rtlCol="0" anchor="ctr" wrap="square"/>
+          <a:bodyPr wrap="square" rtlCol="0" anchor="ctr"/>
           <a:lstStyle/>
           <a:p>
             <a:pPr algn="l">
@@ -5756,6 +5951,11 @@
                 <a:spcPts val="800"/>
               </a:spcAft>
             </a:pPr>
+            <a:endParaRPr dirty="0">
+              <a:solidFill>
+                <a:schemeClr val="tx1"/>
+              </a:solidFill>
+            </a:endParaRPr>
           </a:p>
           <a:p>
             <a:pPr algn="l">
@@ -5766,6 +5966,11 @@
             <a:r>
               <a:t>Preguntas y comentarios</a:t>
             </a:r>
+            <a:endParaRPr dirty="0">
+              <a:solidFill>
+                <a:schemeClr val="tx1"/>
+              </a:solidFill>
+            </a:endParaRPr>
           </a:p>
           <a:p>
             <a:pPr algn="l">
@@ -5776,6 +5981,11 @@
             <a:r>
               <a:t>observatorioia@uccuyo.edu.ar</a:t>
             </a:r>
+            <a:endParaRPr dirty="0">
+              <a:solidFill>
+                <a:schemeClr val="tx1"/>
+              </a:solidFill>
+            </a:endParaRPr>
           </a:p>
           <a:p>
             <a:pPr algn="l">
@@ -5783,6 +5993,11 @@
                 <a:spcPts val="800"/>
               </a:spcAft>
             </a:pPr>
+            <a:endParaRPr dirty="0">
+              <a:solidFill>
+                <a:schemeClr val="tx1"/>
+              </a:solidFill>
+            </a:endParaRPr>
           </a:p>
           <a:p>
             <a:pPr algn="l">
@@ -5792,6 +6007,11 @@
             </a:pPr>
             <a:r>
               <a:t>GEMEPH · eph-analyzer.streamlit.app/GEMEPH</a:t>
+            </a:r>
+          </a:p>
+          <a:p>
+            <a:r>
+              <a:t>Observatorio de Inteligencia Artificial · UCCuyo</a:t>
             </a:r>
           </a:p>
         </p:txBody>

</xml_diff>